<commit_message>
Update presentation to appeal to both funders and collaborators
Modify slide 26 to include benefits for collaborators, and update associated metadata.

Replit-Commit-Author: Agent
Replit-Commit-Session-Id: 075aae1d-96f4-48c3-9432-c442ac3f20f6
Replit-Commit-Checkpoint-Type: full_checkpoint
Replit-Commit-Event-Id: d1d4d886-e0d0-4386-95f4-cf70dd984c98
Replit-Commit-Screenshot-Url: https://storage.googleapis.com/screenshot-production-us-central1/55376bb2-2aea-463e-b6a9-2c1d5c123d53/075aae1d-96f4-48c3-9432-c442ac3f20f6/VWvuZS4
Replit-Helium-Checkpoint-Created: true
</commit_message>
<xml_diff>
--- a/ThriveUp_ACOS_Complete_Briefing.pptx
+++ b/ThriveUp_ACOS_Complete_Briefing.pptx
@@ -2115,7 +2115,7 @@
           <a:p>
             <a:r>
               <a:rPr lang="en-US" dirty="0"/>
-              <a:t>Here's what makes this different for funders. First, measurable outcomes — we lock Census baselines with verifiable improvement targets and track gaps in real time. Funders see progress, not just promises. Second, coordinated intervention — 24 platforms working as autonomous agents, not siloed tools. Risk factors automatically route to the right platform. Third, transparent and defensible — every inter-platform exchange has documented reasoning. AI decisions are auditable. Implementation science frameworks validate our approach. And fourth, grant-ready deliverables — funder-specific narratives, logic models, evidence packages, and 90-day action plans with clear platform accountability. This is the infrastructure funders wish every grantee had.</a:t>
+              <a:t>This slide speaks to both funders and collaborators — because organizations like Measure Austin, United Way, and local coalitions need to see what they gain from partnering with us, not just what a funder gets for their money. For funders: measurable outcomes with locked Census baselines, real-time gap tracking, and automated reporting. For collaborators: shared data infrastructure — tract-level community data, GIS mapping, and 8 federal data sources already integrated and actionable. Both get coordinated intervention through 24 autonomous platforms with documented reasoning on every exchange. And both get ready-made deliverables — funders get grant narratives and logic models, collaborators get community data packages, shared dashboards, and API access to co-build on our infrastructure. The value proposition is different but equally strong: funders see accountability, collaborators see infrastructure they don't have to build themselves.</a:t>
             </a:r>
             <a:endParaRPr lang="en-US" dirty="0"/>
           </a:p>
@@ -20615,7 +20615,7 @@
                 <a:ea typeface="Arial" pitchFamily="34" charset="-122"/>
                 <a:cs typeface="Arial" pitchFamily="34" charset="-120"/>
               </a:rPr>
-              <a:t>WHAT FUNDERS GET</a:t>
+              <a:t>WHAT FUNDERS &amp; COLLABORATORS GET</a:t>
             </a:r>
             <a:endParaRPr lang="en-US" sz="1100" dirty="0"/>
           </a:p>
@@ -20654,7 +20654,7 @@
                 <a:ea typeface="Arial" pitchFamily="34" charset="-122"/>
                 <a:cs typeface="Arial" pitchFamily="34" charset="-120"/>
               </a:rPr>
-              <a:t>Infrastructure Funders Wish Every Grantee Had</a:t>
+              <a:t>Why Partner With Us — Whether You Fund or Build</a:t>
             </a:r>
             <a:endParaRPr lang="en-US" sz="2400" dirty="0"/>
           </a:p>
@@ -20720,7 +20720,7 @@
                 <a:ea typeface="Arial" pitchFamily="34" charset="-122"/>
                 <a:cs typeface="Arial" pitchFamily="34" charset="-120"/>
               </a:rPr>
-              <a:t>Measurable Outcomes</a:t>
+              <a:t>For Funders: Measurable ROI</a:t>
             </a:r>
             <a:endParaRPr lang="en-US" sz="1600" dirty="0"/>
           </a:p>
@@ -20798,7 +20798,7 @@
                 <a:ea typeface="Arial" pitchFamily="34" charset="-122"/>
                 <a:cs typeface="Arial" pitchFamily="34" charset="-120"/>
               </a:rPr>
-              <a:t>✓  Real-time gap tracking</a:t>
+              <a:t>✓  Real-time gap tracking dashboards</a:t>
             </a:r>
             <a:endParaRPr lang="en-US" sz="1200" dirty="0"/>
           </a:p>
@@ -20837,7 +20837,7 @@
                 <a:ea typeface="Arial" pitchFamily="34" charset="-122"/>
                 <a:cs typeface="Arial" pitchFamily="34" charset="-120"/>
               </a:rPr>
-              <a:t>✓  Platform health monitoring</a:t>
+              <a:t>✓  Automated outcome reporting</a:t>
             </a:r>
             <a:endParaRPr lang="en-US" sz="1200" dirty="0"/>
           </a:p>
@@ -20876,7 +20876,7 @@
                 <a:ea typeface="Arial" pitchFamily="34" charset="-122"/>
                 <a:cs typeface="Arial" pitchFamily="34" charset="-120"/>
               </a:rPr>
-              <a:t>✓  Automated outcome reporting</a:t>
+              <a:t>✓  Grant-specific narratives &amp; logic models</a:t>
             </a:r>
             <a:endParaRPr lang="en-US" sz="1200" dirty="0"/>
           </a:p>
@@ -20942,7 +20942,7 @@
                 <a:ea typeface="Arial" pitchFamily="34" charset="-122"/>
                 <a:cs typeface="Arial" pitchFamily="34" charset="-120"/>
               </a:rPr>
-              <a:t>Coordinated Intervention</a:t>
+              <a:t>For Collaborators: Shared Infrastructure</a:t>
             </a:r>
             <a:endParaRPr lang="en-US" sz="1600" dirty="0"/>
           </a:p>
@@ -20981,7 +20981,7 @@
                 <a:ea typeface="Arial" pitchFamily="34" charset="-122"/>
                 <a:cs typeface="Arial" pitchFamily="34" charset="-120"/>
               </a:rPr>
-              <a:t>✓  24 autonomous agent platforms</a:t>
+              <a:t>✓  Tract-level community data access</a:t>
             </a:r>
             <a:endParaRPr lang="en-US" sz="1200" dirty="0"/>
           </a:p>
@@ -21020,7 +21020,7 @@
                 <a:ea typeface="Arial" pitchFamily="34" charset="-122"/>
                 <a:cs typeface="Arial" pitchFamily="34" charset="-120"/>
               </a:rPr>
-              <a:t>✓  Risk-to-platform routing</a:t>
+              <a:t>✓  8 federal data sources integrated</a:t>
             </a:r>
             <a:endParaRPr lang="en-US" sz="1200" dirty="0"/>
           </a:p>
@@ -21059,7 +21059,7 @@
                 <a:ea typeface="Arial" pitchFamily="34" charset="-122"/>
                 <a:cs typeface="Arial" pitchFamily="34" charset="-120"/>
               </a:rPr>
-              <a:t>✓  Domain alignment validation</a:t>
+              <a:t>✓  GIS mapping &amp; visualization tools</a:t>
             </a:r>
             <a:endParaRPr lang="en-US" sz="1200" dirty="0"/>
           </a:p>
@@ -21098,7 +21098,7 @@
                 <a:ea typeface="Arial" pitchFamily="34" charset="-122"/>
                 <a:cs typeface="Arial" pitchFamily="34" charset="-120"/>
               </a:rPr>
-              <a:t>✓  90-day action plans</a:t>
+              <a:t>✓  API access to co-build solutions</a:t>
             </a:r>
             <a:endParaRPr lang="en-US" sz="1200" dirty="0"/>
           </a:p>
@@ -21164,7 +21164,7 @@
                 <a:ea typeface="Arial" pitchFamily="34" charset="-122"/>
                 <a:cs typeface="Arial" pitchFamily="34" charset="-120"/>
               </a:rPr>
-              <a:t>Transparent &amp; Defensible</a:t>
+              <a:t>For Both: Coordinated Impact</a:t>
             </a:r>
             <a:endParaRPr lang="en-US" sz="1600" dirty="0"/>
           </a:p>
@@ -21203,7 +21203,7 @@
                 <a:ea typeface="Arial" pitchFamily="34" charset="-122"/>
                 <a:cs typeface="Arial" pitchFamily="34" charset="-120"/>
               </a:rPr>
-              <a:t>✓  Documented reasoning on every exchange</a:t>
+              <a:t>✓  24 autonomous platforms — not siloed tools</a:t>
             </a:r>
             <a:endParaRPr lang="en-US" sz="1200" dirty="0"/>
           </a:p>
@@ -21242,7 +21242,7 @@
                 <a:ea typeface="Arial" pitchFamily="34" charset="-122"/>
                 <a:cs typeface="Arial" pitchFamily="34" charset="-120"/>
               </a:rPr>
-              <a:t>✓  Auditable AI decisions</a:t>
+              <a:t>✓  Risk-to-platform routing</a:t>
             </a:r>
             <a:endParaRPr lang="en-US" sz="1200" dirty="0"/>
           </a:p>
@@ -21281,7 +21281,7 @@
                 <a:ea typeface="Arial" pitchFamily="34" charset="-122"/>
                 <a:cs typeface="Arial" pitchFamily="34" charset="-120"/>
               </a:rPr>
-              <a:t>✓  CFIR &amp; RE-AIM validation</a:t>
+              <a:t>✓  Documented reasoning on every exchange</a:t>
             </a:r>
             <a:endParaRPr lang="en-US" sz="1200" dirty="0"/>
           </a:p>
@@ -21320,7 +21320,7 @@
                 <a:ea typeface="Arial" pitchFamily="34" charset="-122"/>
                 <a:cs typeface="Arial" pitchFamily="34" charset="-120"/>
               </a:rPr>
-              <a:t>✓  Implementation science frameworks</a:t>
+              <a:t>✓  CFIR &amp; RE-AIM validated frameworks</a:t>
             </a:r>
             <a:endParaRPr lang="en-US" sz="1200" dirty="0"/>
           </a:p>
@@ -21386,7 +21386,7 @@
                 <a:ea typeface="Arial" pitchFamily="34" charset="-122"/>
                 <a:cs typeface="Arial" pitchFamily="34" charset="-120"/>
               </a:rPr>
-              <a:t>Grant-Ready Deliverables</a:t>
+              <a:t>For Both: Ready-Made Deliverables</a:t>
             </a:r>
             <a:endParaRPr lang="en-US" sz="1600" dirty="0"/>
           </a:p>
@@ -21425,7 +21425,7 @@
                 <a:ea typeface="Arial" pitchFamily="34" charset="-122"/>
                 <a:cs typeface="Arial" pitchFamily="34" charset="-120"/>
               </a:rPr>
-              <a:t>✓  Funder-specific narratives (8 profiles)</a:t>
+              <a:t>✓  Community data packages</a:t>
             </a:r>
             <a:endParaRPr lang="en-US" sz="1200" dirty="0"/>
           </a:p>
@@ -21464,7 +21464,7 @@
                 <a:ea typeface="Arial" pitchFamily="34" charset="-122"/>
                 <a:cs typeface="Arial" pitchFamily="34" charset="-120"/>
               </a:rPr>
-              <a:t>✓  Logic models &amp; evidence packages</a:t>
+              <a:t>✓  Impact dashboards &amp; CSV export</a:t>
             </a:r>
             <a:endParaRPr lang="en-US" sz="1200" dirty="0"/>
           </a:p>
@@ -21503,7 +21503,7 @@
                 <a:ea typeface="Arial" pitchFamily="34" charset="-122"/>
                 <a:cs typeface="Arial" pitchFamily="34" charset="-120"/>
               </a:rPr>
-              <a:t>✓  Budget templates</a:t>
+              <a:t>✓  Evidence packages &amp; budget templates</a:t>
             </a:r>
             <a:endParaRPr lang="en-US" sz="1200" dirty="0"/>
           </a:p>
@@ -21542,7 +21542,7 @@
                 <a:ea typeface="Arial" pitchFamily="34" charset="-122"/>
                 <a:cs typeface="Arial" pitchFamily="34" charset="-120"/>
               </a:rPr>
-              <a:t>✓  Community data packages</a:t>
+              <a:t>✓  90-day action plans with accountability</a:t>
             </a:r>
             <a:endParaRPr lang="en-US" sz="1200" dirty="0"/>
           </a:p>

</xml_diff>